<commit_message>
Update plotting scripts, archive test parameter sweeps
</commit_message>
<xml_diff>
--- a/figures/edited/fig4_edited.pptx
+++ b/figures/edited/fig4_edited.pptx
@@ -104,6 +104,11 @@
       </a:defRPr>
     </a:lvl9pPr>
   </p:defaultTextStyle>
+  <p:extLst>
+    <p:ext uri="{EFAFB233-063F-42B5-8137-9DF3F51BA10A}">
+      <p15:sldGuideLst xmlns:p15="http://schemas.microsoft.com/office/powerpoint/2012/main"/>
+    </p:ext>
+  </p:extLst>
 </p:presentation>
 </file>
 
@@ -238,7 +243,7 @@
           <a:p>
             <a:fld id="{B289AAA1-CD3E-6343-8C47-490C1B21047E}" type="datetimeFigureOut">
               <a:rPr lang="en-US" smtClean="0"/>
-              <a:t>6/1/26</a:t>
+              <a:t>6/17/26</a:t>
             </a:fld>
             <a:endParaRPr lang="en-US"/>
           </a:p>
@@ -408,7 +413,7 @@
           <a:p>
             <a:fld id="{B289AAA1-CD3E-6343-8C47-490C1B21047E}" type="datetimeFigureOut">
               <a:rPr lang="en-US" smtClean="0"/>
-              <a:t>6/1/26</a:t>
+              <a:t>6/17/26</a:t>
             </a:fld>
             <a:endParaRPr lang="en-US"/>
           </a:p>
@@ -588,7 +593,7 @@
           <a:p>
             <a:fld id="{B289AAA1-CD3E-6343-8C47-490C1B21047E}" type="datetimeFigureOut">
               <a:rPr lang="en-US" smtClean="0"/>
-              <a:t>6/1/26</a:t>
+              <a:t>6/17/26</a:t>
             </a:fld>
             <a:endParaRPr lang="en-US"/>
           </a:p>
@@ -758,7 +763,7 @@
           <a:p>
             <a:fld id="{B289AAA1-CD3E-6343-8C47-490C1B21047E}" type="datetimeFigureOut">
               <a:rPr lang="en-US" smtClean="0"/>
-              <a:t>6/1/26</a:t>
+              <a:t>6/17/26</a:t>
             </a:fld>
             <a:endParaRPr lang="en-US"/>
           </a:p>
@@ -1004,7 +1009,7 @@
           <a:p>
             <a:fld id="{B289AAA1-CD3E-6343-8C47-490C1B21047E}" type="datetimeFigureOut">
               <a:rPr lang="en-US" smtClean="0"/>
-              <a:t>6/1/26</a:t>
+              <a:t>6/17/26</a:t>
             </a:fld>
             <a:endParaRPr lang="en-US"/>
           </a:p>
@@ -1236,7 +1241,7 @@
           <a:p>
             <a:fld id="{B289AAA1-CD3E-6343-8C47-490C1B21047E}" type="datetimeFigureOut">
               <a:rPr lang="en-US" smtClean="0"/>
-              <a:t>6/1/26</a:t>
+              <a:t>6/17/26</a:t>
             </a:fld>
             <a:endParaRPr lang="en-US"/>
           </a:p>
@@ -1603,7 +1608,7 @@
           <a:p>
             <a:fld id="{B289AAA1-CD3E-6343-8C47-490C1B21047E}" type="datetimeFigureOut">
               <a:rPr lang="en-US" smtClean="0"/>
-              <a:t>6/1/26</a:t>
+              <a:t>6/17/26</a:t>
             </a:fld>
             <a:endParaRPr lang="en-US"/>
           </a:p>
@@ -1721,7 +1726,7 @@
           <a:p>
             <a:fld id="{B289AAA1-CD3E-6343-8C47-490C1B21047E}" type="datetimeFigureOut">
               <a:rPr lang="en-US" smtClean="0"/>
-              <a:t>6/1/26</a:t>
+              <a:t>6/17/26</a:t>
             </a:fld>
             <a:endParaRPr lang="en-US"/>
           </a:p>
@@ -1816,7 +1821,7 @@
           <a:p>
             <a:fld id="{B289AAA1-CD3E-6343-8C47-490C1B21047E}" type="datetimeFigureOut">
               <a:rPr lang="en-US" smtClean="0"/>
-              <a:t>6/1/26</a:t>
+              <a:t>6/17/26</a:t>
             </a:fld>
             <a:endParaRPr lang="en-US"/>
           </a:p>
@@ -2093,7 +2098,7 @@
           <a:p>
             <a:fld id="{B289AAA1-CD3E-6343-8C47-490C1B21047E}" type="datetimeFigureOut">
               <a:rPr lang="en-US" smtClean="0"/>
-              <a:t>6/1/26</a:t>
+              <a:t>6/17/26</a:t>
             </a:fld>
             <a:endParaRPr lang="en-US"/>
           </a:p>
@@ -2350,7 +2355,7 @@
           <a:p>
             <a:fld id="{B289AAA1-CD3E-6343-8C47-490C1B21047E}" type="datetimeFigureOut">
               <a:rPr lang="en-US" smtClean="0"/>
-              <a:t>6/1/26</a:t>
+              <a:t>6/17/26</a:t>
             </a:fld>
             <a:endParaRPr lang="en-US"/>
           </a:p>
@@ -2563,7 +2568,7 @@
           <a:p>
             <a:fld id="{B289AAA1-CD3E-6343-8C47-490C1B21047E}" type="datetimeFigureOut">
               <a:rPr lang="en-US" smtClean="0"/>
-              <a:t>6/1/26</a:t>
+              <a:t>6/17/26</a:t>
             </a:fld>
             <a:endParaRPr lang="en-US"/>
           </a:p>
@@ -2984,9 +2989,8 @@
         </p:nvPicPr>
         <p:blipFill>
           <a:blip r:embed="rId2"/>
-          <a:stretch>
-            <a:fillRect/>
-          </a:stretch>
+          <a:srcRect/>
+          <a:stretch/>
         </p:blipFill>
         <p:spPr>
           <a:xfrm>

</xml_diff>